<commit_message>
Regenerate editable route examples
</commit_message>
<xml_diff>
--- a/examples/campaign-route-demo/outputs/tech-route.pptx
+++ b/examples/campaign-route-demo/outputs/tech-route.pptx
@@ -93,18 +93,18 @@
         </p:nvSpPr>
         <p:spPr>
           <a:xfrm>
-            <a:off x="870000" y="968641"/>
+            <a:off x="869999" y="533014"/>
             <a:ext cx="10452000" cy="430000"/>
           </a:xfrm>
           <a:prstGeom prst="roundRect">
             <a:avLst/>
           </a:prstGeom>
           <a:solidFill>
-            <a:srgbClr val="DCE9FF"/>
-          </a:solidFill>
-          <a:ln w="12700">
-            <a:solidFill>
-              <a:srgbClr val="DCE9FF"/>
+            <a:srgbClr val="FFE4E6"/>
+          </a:solidFill>
+          <a:ln w="12700">
+            <a:solidFill>
+              <a:srgbClr val="FFE4E6"/>
             </a:solidFill>
           </a:ln>
         </p:spPr>
@@ -119,7 +119,7 @@
                   <a:srgbClr val="111827"/>
                 </a:solidFill>
               </a:rPr>
-              <a:t>Campaign Strategy</a:t>
+              <a:t>Research Tool</a:t>
             </a:r>
           </a:p>
           <a:p>
@@ -130,7 +130,18 @@
                   <a:srgbClr val="111827"/>
                 </a:solidFill>
               </a:rPr>
-              <a:t>Route</a:t>
+              <a:t>Launch Campaign</a:t>
+            </a:r>
+          </a:p>
+          <a:p>
+            <a:pPr algn="ctr"/>
+            <a:r>
+              <a:rPr lang="en-US" sz="2100" b="1">
+                <a:solidFill>
+                  <a:srgbClr val="111827"/>
+                </a:solidFill>
+              </a:rPr>
+              <a:t>Strategy Route</a:t>
             </a:r>
           </a:p>
         </p:txBody>
@@ -143,7 +154,7 @@
         </p:nvSpPr>
         <p:spPr>
           <a:xfrm>
-            <a:off x="1700000" y="1413641"/>
+            <a:off x="1699999" y="978014"/>
             <a:ext cx="8792000" cy="190000"/>
           </a:xfrm>
           <a:prstGeom prst="rect">
@@ -166,10 +177,10 @@
             <a:r>
               <a:rPr lang="en-US" sz="850">
                 <a:solidFill>
-                  <a:srgbClr val="526070"/>
-                </a:solidFill>
-              </a:rPr>
-              <a:t>Research-tool</a:t>
+                  <a:srgbClr val="5B6472"/>
+                </a:solidFill>
+              </a:rPr>
+              <a:t>Campaign route</a:t>
             </a:r>
           </a:p>
           <a:p>
@@ -177,10 +188,10 @@
             <a:r>
               <a:rPr lang="en-US" sz="850">
                 <a:solidFill>
-                  <a:srgbClr val="526070"/>
-                </a:solidFill>
-              </a:rPr>
-              <a:t>launch campaign</a:t>
+                  <a:srgbClr val="5B6472"/>
+                </a:solidFill>
+              </a:rPr>
+              <a:t>generated by</a:t>
             </a:r>
           </a:p>
           <a:p>
@@ -188,10 +199,10 @@
             <a:r>
               <a:rPr lang="en-US" sz="850">
                 <a:solidFill>
-                  <a:srgbClr val="526070"/>
-                </a:solidFill>
-              </a:rPr>
-              <a:t>demo</a:t>
+                  <a:srgbClr val="5B6472"/>
+                </a:solidFill>
+              </a:rPr>
+              <a:t>tech-route-maker</a:t>
             </a:r>
           </a:p>
         </p:txBody>
@@ -204,20 +215,19 @@
         </p:nvSpPr>
         <p:spPr>
           <a:xfrm>
-            <a:off x="808423" y="2347053"/>
-            <a:ext cx="1905621" cy="3123683"/>
-          </a:xfrm>
-          <a:prstGeom prst="roundRect">
-            <a:avLst/>
-          </a:prstGeom>
-          <a:solidFill>
-            <a:srgbClr val="DCE9FF"/>
-          </a:solidFill>
-          <a:ln w="12700">
-            <a:solidFill>
-              <a:srgbClr val="AFC4E8"/>
-            </a:solidFill>
-            <a:prstDash val="dash"/>
+            <a:off x="765823" y="1976097"/>
+            <a:ext cx="1619112" cy="3352852"/>
+          </a:xfrm>
+          <a:prstGeom prst="roundRect">
+            <a:avLst/>
+          </a:prstGeom>
+          <a:solidFill>
+            <a:srgbClr val="FFE4E6"/>
+          </a:solidFill>
+          <a:ln w="12700">
+            <a:solidFill>
+              <a:srgbClr val="FDA4AF"/>
+            </a:solidFill>
           </a:ln>
         </p:spPr>
         <p:txBody>
@@ -244,18 +254,18 @@
         </p:nvSpPr>
         <p:spPr>
           <a:xfrm>
-            <a:off x="808423" y="2347053"/>
-            <a:ext cx="1905621" cy="331564"/>
-          </a:xfrm>
-          <a:prstGeom prst="roundRect">
-            <a:avLst/>
-          </a:prstGeom>
-          <a:solidFill>
-            <a:srgbClr val="2D5CA8"/>
-          </a:solidFill>
-          <a:ln w="12700">
-            <a:solidFill>
-              <a:srgbClr val="2D5CA8"/>
+            <a:off x="765823" y="1976097"/>
+            <a:ext cx="1619112" cy="326688"/>
+          </a:xfrm>
+          <a:prstGeom prst="roundRect">
+            <a:avLst/>
+          </a:prstGeom>
+          <a:solidFill>
+            <a:srgbClr val="E11D48"/>
+          </a:solidFill>
+          <a:ln w="12700">
+            <a:solidFill>
+              <a:srgbClr val="E11D48"/>
             </a:solidFill>
           </a:ln>
         </p:spPr>
@@ -283,20 +293,19 @@
         </p:nvSpPr>
         <p:spPr>
           <a:xfrm>
-            <a:off x="2975806" y="2347053"/>
-            <a:ext cx="1905621" cy="3123683"/>
-          </a:xfrm>
-          <a:prstGeom prst="roundRect">
-            <a:avLst/>
-          </a:prstGeom>
-          <a:solidFill>
-            <a:srgbClr val="DFF2E3"/>
-          </a:solidFill>
-          <a:ln w="12700">
-            <a:solidFill>
-              <a:srgbClr val="AFC4E8"/>
-            </a:solidFill>
-            <a:prstDash val="dash"/>
+            <a:off x="2574071" y="1976097"/>
+            <a:ext cx="1619112" cy="3352852"/>
+          </a:xfrm>
+          <a:prstGeom prst="roundRect">
+            <a:avLst/>
+          </a:prstGeom>
+          <a:solidFill>
+            <a:srgbClr val="FEF3C7"/>
+          </a:solidFill>
+          <a:ln w="12700">
+            <a:solidFill>
+              <a:srgbClr val="FDA4AF"/>
+            </a:solidFill>
           </a:ln>
         </p:spPr>
         <p:txBody>
@@ -323,18 +332,18 @@
         </p:nvSpPr>
         <p:spPr>
           <a:xfrm>
-            <a:off x="2975806" y="2347053"/>
-            <a:ext cx="1905621" cy="331564"/>
-          </a:xfrm>
-          <a:prstGeom prst="roundRect">
-            <a:avLst/>
-          </a:prstGeom>
-          <a:solidFill>
-            <a:srgbClr val="2D5CA8"/>
-          </a:solidFill>
-          <a:ln w="12700">
-            <a:solidFill>
-              <a:srgbClr val="2D5CA8"/>
+            <a:off x="2574071" y="1976097"/>
+            <a:ext cx="1619112" cy="326688"/>
+          </a:xfrm>
+          <a:prstGeom prst="roundRect">
+            <a:avLst/>
+          </a:prstGeom>
+          <a:solidFill>
+            <a:srgbClr val="E11D48"/>
+          </a:solidFill>
+          <a:ln w="12700">
+            <a:solidFill>
+              <a:srgbClr val="E11D48"/>
             </a:solidFill>
           </a:ln>
         </p:spPr>
@@ -362,20 +371,19 @@
         </p:nvSpPr>
         <p:spPr>
           <a:xfrm>
-            <a:off x="5143189" y="2347053"/>
-            <a:ext cx="1905621" cy="3123683"/>
-          </a:xfrm>
-          <a:prstGeom prst="roundRect">
-            <a:avLst/>
-          </a:prstGeom>
-          <a:solidFill>
-            <a:srgbClr val="E9EEFF"/>
-          </a:solidFill>
-          <a:ln w="12700">
-            <a:solidFill>
-              <a:srgbClr val="AFC4E8"/>
-            </a:solidFill>
-            <a:prstDash val="dash"/>
+            <a:off x="4382319" y="1976097"/>
+            <a:ext cx="1619112" cy="3352852"/>
+          </a:xfrm>
+          <a:prstGeom prst="roundRect">
+            <a:avLst/>
+          </a:prstGeom>
+          <a:solidFill>
+            <a:srgbClr val="DBEAFE"/>
+          </a:solidFill>
+          <a:ln w="12700">
+            <a:solidFill>
+              <a:srgbClr val="FDA4AF"/>
+            </a:solidFill>
           </a:ln>
         </p:spPr>
         <p:txBody>
@@ -402,18 +410,18 @@
         </p:nvSpPr>
         <p:spPr>
           <a:xfrm>
-            <a:off x="5143189" y="2347053"/>
-            <a:ext cx="1905621" cy="331564"/>
-          </a:xfrm>
-          <a:prstGeom prst="roundRect">
-            <a:avLst/>
-          </a:prstGeom>
-          <a:solidFill>
-            <a:srgbClr val="2D5CA8"/>
-          </a:solidFill>
-          <a:ln w="12700">
-            <a:solidFill>
-              <a:srgbClr val="2D5CA8"/>
+            <a:off x="4382319" y="1976097"/>
+            <a:ext cx="1619112" cy="326688"/>
+          </a:xfrm>
+          <a:prstGeom prst="roundRect">
+            <a:avLst/>
+          </a:prstGeom>
+          <a:solidFill>
+            <a:srgbClr val="E11D48"/>
+          </a:solidFill>
+          <a:ln w="12700">
+            <a:solidFill>
+              <a:srgbClr val="E11D48"/>
             </a:solidFill>
           </a:ln>
         </p:spPr>
@@ -441,20 +449,19 @@
         </p:nvSpPr>
         <p:spPr>
           <a:xfrm>
-            <a:off x="7310571" y="2347053"/>
-            <a:ext cx="1905621" cy="3123683"/>
-          </a:xfrm>
-          <a:prstGeom prst="roundRect">
-            <a:avLst/>
-          </a:prstGeom>
-          <a:solidFill>
-            <a:srgbClr val="FFF1D6"/>
-          </a:solidFill>
-          <a:ln w="12700">
-            <a:solidFill>
-              <a:srgbClr val="AFC4E8"/>
-            </a:solidFill>
-            <a:prstDash val="dash"/>
+            <a:off x="6190567" y="1976097"/>
+            <a:ext cx="1619112" cy="3352852"/>
+          </a:xfrm>
+          <a:prstGeom prst="roundRect">
+            <a:avLst/>
+          </a:prstGeom>
+          <a:solidFill>
+            <a:srgbClr val="DCFCE7"/>
+          </a:solidFill>
+          <a:ln w="12700">
+            <a:solidFill>
+              <a:srgbClr val="FDA4AF"/>
+            </a:solidFill>
           </a:ln>
         </p:spPr>
         <p:txBody>
@@ -481,18 +488,18 @@
         </p:nvSpPr>
         <p:spPr>
           <a:xfrm>
-            <a:off x="7310571" y="2347053"/>
-            <a:ext cx="1905621" cy="331564"/>
-          </a:xfrm>
-          <a:prstGeom prst="roundRect">
-            <a:avLst/>
-          </a:prstGeom>
-          <a:solidFill>
-            <a:srgbClr val="2D5CA8"/>
-          </a:solidFill>
-          <a:ln w="12700">
-            <a:solidFill>
-              <a:srgbClr val="2D5CA8"/>
+            <a:off x="6190567" y="1976097"/>
+            <a:ext cx="1619112" cy="326688"/>
+          </a:xfrm>
+          <a:prstGeom prst="roundRect">
+            <a:avLst/>
+          </a:prstGeom>
+          <a:solidFill>
+            <a:srgbClr val="E11D48"/>
+          </a:solidFill>
+          <a:ln w="12700">
+            <a:solidFill>
+              <a:srgbClr val="E11D48"/>
             </a:solidFill>
           </a:ln>
         </p:spPr>
@@ -520,20 +527,19 @@
         </p:nvSpPr>
         <p:spPr>
           <a:xfrm>
-            <a:off x="9477954" y="2347053"/>
-            <a:ext cx="1905621" cy="3123683"/>
-          </a:xfrm>
-          <a:prstGeom prst="roundRect">
-            <a:avLst/>
-          </a:prstGeom>
-          <a:solidFill>
-            <a:srgbClr val="E4F6F5"/>
-          </a:solidFill>
-          <a:ln w="12700">
-            <a:solidFill>
-              <a:srgbClr val="AFC4E8"/>
-            </a:solidFill>
-            <a:prstDash val="dash"/>
+            <a:off x="7998815" y="1976097"/>
+            <a:ext cx="1619112" cy="3352852"/>
+          </a:xfrm>
+          <a:prstGeom prst="roundRect">
+            <a:avLst/>
+          </a:prstGeom>
+          <a:solidFill>
+            <a:srgbClr val="FCE7F3"/>
+          </a:solidFill>
+          <a:ln w="12700">
+            <a:solidFill>
+              <a:srgbClr val="FDA4AF"/>
+            </a:solidFill>
           </a:ln>
         </p:spPr>
         <p:txBody>
@@ -560,18 +566,18 @@
         </p:nvSpPr>
         <p:spPr>
           <a:xfrm>
-            <a:off x="9477954" y="2347053"/>
-            <a:ext cx="1905621" cy="331564"/>
-          </a:xfrm>
-          <a:prstGeom prst="roundRect">
-            <a:avLst/>
-          </a:prstGeom>
-          <a:solidFill>
-            <a:srgbClr val="2D5CA8"/>
-          </a:solidFill>
-          <a:ln w="12700">
-            <a:solidFill>
-              <a:srgbClr val="2D5CA8"/>
+            <a:off x="7998815" y="1976097"/>
+            <a:ext cx="1619112" cy="326688"/>
+          </a:xfrm>
+          <a:prstGeom prst="roundRect">
+            <a:avLst/>
+          </a:prstGeom>
+          <a:solidFill>
+            <a:srgbClr val="E11D48"/>
+          </a:solidFill>
+          <a:ln w="12700">
+            <a:solidFill>
+              <a:srgbClr val="E11D48"/>
             </a:solidFill>
           </a:ln>
         </p:spPr>
@@ -591,50 +597,84 @@
           </a:p>
         </p:txBody>
       </p:sp>
-      <p:cxnSp>
-        <p:nvCxnSpPr>
-          <p:cNvPr id="14" name="Connector 14"/>
-          <p:cNvCxnSpPr/>
-          <p:nvPr/>
-        </p:nvCxnSpPr>
-        <p:spPr>
-          <a:xfrm>
-            <a:off x="1761234" y="3141062"/>
-            <a:ext cx="2167382" cy="1"/>
-          </a:xfrm>
-          <a:prstGeom prst="line">
-            <a:avLst/>
-          </a:prstGeom>
-          <a:ln w="19050">
-            <a:solidFill>
-              <a:srgbClr val="2D5CA8"/>
-            </a:solidFill>
-            <a:headEnd type="triangle"/>
-          </a:ln>
-        </p:spPr>
-      </p:cxnSp>
-      <p:cxnSp>
-        <p:nvCxnSpPr>
-          <p:cNvPr id="15" name="Connector 15"/>
-          <p:cNvCxnSpPr/>
-          <p:nvPr/>
-        </p:nvCxnSpPr>
-        <p:spPr>
-          <a:xfrm>
-            <a:off x="3928617" y="3141062"/>
-            <a:ext cx="2167382" cy="1"/>
-          </a:xfrm>
-          <a:prstGeom prst="line">
-            <a:avLst/>
-          </a:prstGeom>
-          <a:ln w="19050">
-            <a:solidFill>
-              <a:srgbClr val="2D5CA8"/>
-            </a:solidFill>
-            <a:headEnd type="triangle"/>
-          </a:ln>
-        </p:spPr>
-      </p:cxnSp>
+      <p:sp>
+        <p:nvSpPr>
+          <p:cNvPr id="14" name="Stage Optimization"/>
+          <p:cNvSpPr/>
+          <p:nvPr/>
+        </p:nvSpPr>
+        <p:spPr>
+          <a:xfrm>
+            <a:off x="9807063" y="1976097"/>
+            <a:ext cx="1619112" cy="3352852"/>
+          </a:xfrm>
+          <a:prstGeom prst="roundRect">
+            <a:avLst/>
+          </a:prstGeom>
+          <a:solidFill>
+            <a:srgbClr val="E0F2FE"/>
+          </a:solidFill>
+          <a:ln w="12700">
+            <a:solidFill>
+              <a:srgbClr val="FDA4AF"/>
+            </a:solidFill>
+          </a:ln>
+        </p:spPr>
+        <p:txBody>
+          <a:bodyPr wrap="square" anchor="ctr"/>
+          <a:lstStyle/>
+          <a:p>
+            <a:pPr algn="ctr"/>
+            <a:r>
+              <a:rPr lang="en-US" sz="1000">
+                <a:solidFill>
+                  <a:srgbClr val="111827"/>
+                </a:solidFill>
+              </a:rPr>
+              <a:t/>
+            </a:r>
+          </a:p>
+        </p:txBody>
+      </p:sp>
+      <p:sp>
+        <p:nvSpPr>
+          <p:cNvPr id="15" name="Header Optimization"/>
+          <p:cNvSpPr/>
+          <p:nvPr/>
+        </p:nvSpPr>
+        <p:spPr>
+          <a:xfrm>
+            <a:off x="9807063" y="1976097"/>
+            <a:ext cx="1619112" cy="326688"/>
+          </a:xfrm>
+          <a:prstGeom prst="roundRect">
+            <a:avLst/>
+          </a:prstGeom>
+          <a:solidFill>
+            <a:srgbClr val="E11D48"/>
+          </a:solidFill>
+          <a:ln w="12700">
+            <a:solidFill>
+              <a:srgbClr val="E11D48"/>
+            </a:solidFill>
+          </a:ln>
+        </p:spPr>
+        <p:txBody>
+          <a:bodyPr wrap="square" anchor="ctr"/>
+          <a:lstStyle/>
+          <a:p>
+            <a:pPr algn="ctr"/>
+            <a:r>
+              <a:rPr lang="en-US" sz="1100" b="1">
+                <a:solidFill>
+                  <a:srgbClr val="FFFFFF"/>
+                </a:solidFill>
+              </a:rPr>
+              <a:t>Optimization</a:t>
+            </a:r>
+          </a:p>
+        </p:txBody>
+      </p:sp>
       <p:cxnSp>
         <p:nvCxnSpPr>
           <p:cNvPr id="16" name="Connector 16"/>
@@ -643,15 +683,15 @@
         </p:nvCxnSpPr>
         <p:spPr>
           <a:xfrm>
-            <a:off x="6096000" y="3141062"/>
-            <a:ext cx="1" cy="680579"/>
+            <a:off x="1575379" y="2827205"/>
+            <a:ext cx="1" cy="670570"/>
           </a:xfrm>
           <a:prstGeom prst="line">
             <a:avLst/>
           </a:prstGeom>
           <a:ln w="19050">
             <a:solidFill>
-              <a:srgbClr val="2D5CA8"/>
+              <a:srgbClr val="E11D48"/>
             </a:solidFill>
             <a:headEnd type="triangle"/>
           </a:ln>
@@ -665,15 +705,15 @@
         </p:nvCxnSpPr>
         <p:spPr>
           <a:xfrm flipV="1">
-            <a:off x="6096000" y="3141062"/>
-            <a:ext cx="2167382" cy="680579"/>
+            <a:off x="1575379" y="2827205"/>
+            <a:ext cx="1808248" cy="670570"/>
           </a:xfrm>
           <a:prstGeom prst="line">
             <a:avLst/>
           </a:prstGeom>
           <a:ln w="19050">
             <a:solidFill>
-              <a:srgbClr val="2D5CA8"/>
+              <a:srgbClr val="E11D48"/>
             </a:solidFill>
             <a:headEnd type="triangle"/>
           </a:ln>
@@ -687,15 +727,15 @@
         </p:nvCxnSpPr>
         <p:spPr>
           <a:xfrm>
-            <a:off x="8263382" y="3141062"/>
-            <a:ext cx="1" cy="680579"/>
+            <a:off x="3383627" y="2827205"/>
+            <a:ext cx="1" cy="670570"/>
           </a:xfrm>
           <a:prstGeom prst="line">
             <a:avLst/>
           </a:prstGeom>
           <a:ln w="19050">
             <a:solidFill>
-              <a:srgbClr val="2D5CA8"/>
+              <a:srgbClr val="E11D48"/>
             </a:solidFill>
             <a:headEnd type="triangle"/>
           </a:ln>
@@ -709,15 +749,15 @@
         </p:nvCxnSpPr>
         <p:spPr>
           <a:xfrm flipV="1">
-            <a:off x="8263382" y="3141062"/>
-            <a:ext cx="2167382" cy="680579"/>
+            <a:off x="3383627" y="2827205"/>
+            <a:ext cx="1808248" cy="670570"/>
           </a:xfrm>
           <a:prstGeom prst="line">
             <a:avLst/>
           </a:prstGeom>
           <a:ln w="19050">
             <a:solidFill>
-              <a:srgbClr val="2D5CA8"/>
+              <a:srgbClr val="E11D48"/>
             </a:solidFill>
             <a:headEnd type="triangle"/>
           </a:ln>
@@ -731,15 +771,15 @@
         </p:nvCxnSpPr>
         <p:spPr>
           <a:xfrm>
-            <a:off x="10430765" y="3141062"/>
-            <a:ext cx="1" cy="680579"/>
+            <a:off x="5191875" y="2827205"/>
+            <a:ext cx="1" cy="670570"/>
           </a:xfrm>
           <a:prstGeom prst="line">
             <a:avLst/>
           </a:prstGeom>
           <a:ln w="19050">
             <a:solidFill>
-              <a:srgbClr val="2D5CA8"/>
+              <a:srgbClr val="E11D48"/>
             </a:solidFill>
             <a:headEnd type="triangle"/>
           </a:ln>
@@ -752,31 +792,141 @@
           <p:nvPr/>
         </p:nvCxnSpPr>
         <p:spPr>
-          <a:xfrm flipH="1" flipV="1">
-            <a:off x="6096000" y="3141062"/>
-            <a:ext cx="4334765" cy="680579"/>
+          <a:xfrm flipV="1">
+            <a:off x="5191875" y="2827205"/>
+            <a:ext cx="1808248" cy="670570"/>
           </a:xfrm>
           <a:prstGeom prst="line">
             <a:avLst/>
           </a:prstGeom>
           <a:ln w="19050">
             <a:solidFill>
-              <a:srgbClr val="2D5CA8"/>
+              <a:srgbClr val="E11D48"/>
             </a:solidFill>
             <a:headEnd type="triangle"/>
           </a:ln>
         </p:spPr>
       </p:cxnSp>
-      <p:sp>
-        <p:nvSpPr>
-          <p:cNvPr id="22" name="Node audience_segments"/>
-          <p:cNvSpPr/>
-          <p:nvPr/>
-        </p:nvSpPr>
-        <p:spPr>
-          <a:xfrm>
-            <a:off x="991656" y="2870576"/>
-            <a:ext cx="1539155" cy="540973"/>
+      <p:cxnSp>
+        <p:nvCxnSpPr>
+          <p:cNvPr id="22" name="Connector 22"/>
+          <p:cNvCxnSpPr/>
+          <p:nvPr/>
+        </p:nvCxnSpPr>
+        <p:spPr>
+          <a:xfrm>
+            <a:off x="7000124" y="2827205"/>
+            <a:ext cx="1" cy="670570"/>
+          </a:xfrm>
+          <a:prstGeom prst="line">
+            <a:avLst/>
+          </a:prstGeom>
+          <a:ln w="19050">
+            <a:solidFill>
+              <a:srgbClr val="E11D48"/>
+            </a:solidFill>
+            <a:headEnd type="triangle"/>
+          </a:ln>
+        </p:spPr>
+      </p:cxnSp>
+      <p:cxnSp>
+        <p:nvCxnSpPr>
+          <p:cNvPr id="23" name="Connector 23"/>
+          <p:cNvCxnSpPr/>
+          <p:nvPr/>
+        </p:nvCxnSpPr>
+        <p:spPr>
+          <a:xfrm flipV="1">
+            <a:off x="7000124" y="2827205"/>
+            <a:ext cx="1808248" cy="670570"/>
+          </a:xfrm>
+          <a:prstGeom prst="line">
+            <a:avLst/>
+          </a:prstGeom>
+          <a:ln w="19050">
+            <a:solidFill>
+              <a:srgbClr val="E11D48"/>
+            </a:solidFill>
+            <a:headEnd type="triangle"/>
+          </a:ln>
+        </p:spPr>
+      </p:cxnSp>
+      <p:cxnSp>
+        <p:nvCxnSpPr>
+          <p:cNvPr id="24" name="Connector 24"/>
+          <p:cNvCxnSpPr/>
+          <p:nvPr/>
+        </p:nvCxnSpPr>
+        <p:spPr>
+          <a:xfrm>
+            <a:off x="8808372" y="2827205"/>
+            <a:ext cx="1" cy="670570"/>
+          </a:xfrm>
+          <a:prstGeom prst="line">
+            <a:avLst/>
+          </a:prstGeom>
+          <a:ln w="19050">
+            <a:solidFill>
+              <a:srgbClr val="E11D48"/>
+            </a:solidFill>
+            <a:headEnd type="triangle"/>
+          </a:ln>
+        </p:spPr>
+      </p:cxnSp>
+      <p:cxnSp>
+        <p:nvCxnSpPr>
+          <p:cNvPr id="25" name="Connector 25"/>
+          <p:cNvCxnSpPr/>
+          <p:nvPr/>
+        </p:nvCxnSpPr>
+        <p:spPr>
+          <a:xfrm flipV="1">
+            <a:off x="8808372" y="2827205"/>
+            <a:ext cx="1808248" cy="670570"/>
+          </a:xfrm>
+          <a:prstGeom prst="line">
+            <a:avLst/>
+          </a:prstGeom>
+          <a:ln w="19050">
+            <a:solidFill>
+              <a:srgbClr val="E11D48"/>
+            </a:solidFill>
+            <a:headEnd type="triangle"/>
+          </a:ln>
+        </p:spPr>
+      </p:cxnSp>
+      <p:cxnSp>
+        <p:nvCxnSpPr>
+          <p:cNvPr id="26" name="Connector 26"/>
+          <p:cNvCxnSpPr/>
+          <p:nvPr/>
+        </p:nvCxnSpPr>
+        <p:spPr>
+          <a:xfrm flipH="1">
+            <a:off x="5191875" y="2827205"/>
+            <a:ext cx="5424744" cy="1"/>
+          </a:xfrm>
+          <a:prstGeom prst="line">
+            <a:avLst/>
+          </a:prstGeom>
+          <a:ln w="19050">
+            <a:solidFill>
+              <a:srgbClr val="E11D48"/>
+            </a:solidFill>
+            <a:headEnd type="triangle"/>
+          </a:ln>
+        </p:spPr>
+      </p:cxnSp>
+      <p:sp>
+        <p:nvSpPr>
+          <p:cNvPr id="27" name="Node audience_segments"/>
+          <p:cNvSpPr/>
+          <p:nvPr/>
+        </p:nvSpPr>
+        <p:spPr>
+          <a:xfrm>
+            <a:off x="911973" y="2560697"/>
+            <a:ext cx="1326812" cy="533017"/>
           </a:xfrm>
           <a:prstGeom prst="roundRect">
             <a:avLst/>
@@ -786,7 +936,7 @@
           </a:solidFill>
           <a:ln w="12700">
             <a:solidFill>
-              <a:srgbClr val="8BADE3"/>
+              <a:srgbClr val="FB7185"/>
             </a:solidFill>
           </a:ln>
         </p:spPr>
@@ -808,14 +958,14 @@
       </p:sp>
       <p:sp>
         <p:nvSpPr>
-          <p:cNvPr id="23" name="Node insight_editable"/>
-          <p:cNvSpPr/>
-          <p:nvPr/>
-        </p:nvSpPr>
-        <p:spPr>
-          <a:xfrm>
-            <a:off x="3159039" y="2870576"/>
-            <a:ext cx="1539155" cy="540973"/>
+          <p:cNvPr id="28" name="Node audience_jobs"/>
+          <p:cNvSpPr/>
+          <p:nvPr/>
+        </p:nvSpPr>
+        <p:spPr>
+          <a:xfrm>
+            <a:off x="911973" y="3231267"/>
+            <a:ext cx="1326812" cy="533017"/>
           </a:xfrm>
           <a:prstGeom prst="roundRect">
             <a:avLst/>
@@ -825,7 +975,57 @@
           </a:solidFill>
           <a:ln w="12700">
             <a:solidFill>
-              <a:srgbClr val="8BADE3"/>
+              <a:srgbClr val="FB7185"/>
+            </a:solidFill>
+          </a:ln>
+        </p:spPr>
+        <p:txBody>
+          <a:bodyPr wrap="square" anchor="ctr"/>
+          <a:lstStyle/>
+          <a:p>
+            <a:pPr algn="ctr"/>
+            <a:r>
+              <a:rPr lang="en-US" sz="1050">
+                <a:solidFill>
+                  <a:srgbClr val="111827"/>
+                </a:solidFill>
+              </a:rPr>
+              <a:t>Clarify workflow</a:t>
+            </a:r>
+          </a:p>
+          <a:p>
+            <a:pPr algn="ctr"/>
+            <a:r>
+              <a:rPr lang="en-US" sz="1050">
+                <a:solidFill>
+                  <a:srgbClr val="111827"/>
+                </a:solidFill>
+              </a:rPr>
+              <a:t>jobs</a:t>
+            </a:r>
+          </a:p>
+        </p:txBody>
+      </p:sp>
+      <p:sp>
+        <p:nvSpPr>
+          <p:cNvPr id="29" name="Node insight_editable"/>
+          <p:cNvSpPr/>
+          <p:nvPr/>
+        </p:nvSpPr>
+        <p:spPr>
+          <a:xfrm>
+            <a:off x="2720221" y="2560697"/>
+            <a:ext cx="1326812" cy="533017"/>
+          </a:xfrm>
+          <a:prstGeom prst="roundRect">
+            <a:avLst/>
+          </a:prstGeom>
+          <a:solidFill>
+            <a:srgbClr val="FFFFFF"/>
+          </a:solidFill>
+          <a:ln w="12700">
+            <a:solidFill>
+              <a:srgbClr val="FB7185"/>
             </a:solidFill>
           </a:ln>
         </p:spPr>
@@ -858,14 +1058,14 @@
       </p:sp>
       <p:sp>
         <p:nvSpPr>
-          <p:cNvPr id="24" name="Node message_positioning"/>
-          <p:cNvSpPr/>
-          <p:nvPr/>
-        </p:nvSpPr>
-        <p:spPr>
-          <a:xfrm>
-            <a:off x="5326422" y="2870576"/>
-            <a:ext cx="1539155" cy="540973"/>
+          <p:cNvPr id="30" name="Node insight_friction"/>
+          <p:cNvSpPr/>
+          <p:nvPr/>
+        </p:nvSpPr>
+        <p:spPr>
+          <a:xfrm>
+            <a:off x="2720221" y="3231267"/>
+            <a:ext cx="1326812" cy="533017"/>
           </a:xfrm>
           <a:prstGeom prst="roundRect">
             <a:avLst/>
@@ -875,7 +1075,57 @@
           </a:solidFill>
           <a:ln w="12700">
             <a:solidFill>
-              <a:srgbClr val="8BADE3"/>
+              <a:srgbClr val="FB7185"/>
+            </a:solidFill>
+          </a:ln>
+        </p:spPr>
+        <p:txBody>
+          <a:bodyPr wrap="square" anchor="ctr"/>
+          <a:lstStyle/>
+          <a:p>
+            <a:pPr algn="ctr"/>
+            <a:r>
+              <a:rPr lang="en-US" sz="1050">
+                <a:solidFill>
+                  <a:srgbClr val="111827"/>
+                </a:solidFill>
+              </a:rPr>
+              <a:t>Remove drawing</a:t>
+            </a:r>
+          </a:p>
+          <a:p>
+            <a:pPr algn="ctr"/>
+            <a:r>
+              <a:rPr lang="en-US" sz="1050">
+                <a:solidFill>
+                  <a:srgbClr val="111827"/>
+                </a:solidFill>
+              </a:rPr>
+              <a:t>friction</a:t>
+            </a:r>
+          </a:p>
+        </p:txBody>
+      </p:sp>
+      <p:sp>
+        <p:nvSpPr>
+          <p:cNvPr id="31" name="Node message_positioning"/>
+          <p:cNvSpPr/>
+          <p:nvPr/>
+        </p:nvSpPr>
+        <p:spPr>
+          <a:xfrm>
+            <a:off x="4528469" y="2560697"/>
+            <a:ext cx="1326812" cy="533017"/>
+          </a:xfrm>
+          <a:prstGeom prst="roundRect">
+            <a:avLst/>
+          </a:prstGeom>
+          <a:solidFill>
+            <a:srgbClr val="FFFFFF"/>
+          </a:solidFill>
+          <a:ln w="12700">
+            <a:solidFill>
+              <a:srgbClr val="FB7185"/>
             </a:solidFill>
           </a:ln>
         </p:spPr>
@@ -908,14 +1158,14 @@
       </p:sp>
       <p:sp>
         <p:nvSpPr>
-          <p:cNvPr id="25" name="Node message_proof"/>
-          <p:cNvSpPr/>
-          <p:nvPr/>
-        </p:nvSpPr>
-        <p:spPr>
-          <a:xfrm>
-            <a:off x="5326422" y="3551155"/>
-            <a:ext cx="1539155" cy="540973"/>
+          <p:cNvPr id="32" name="Node message_proof"/>
+          <p:cNvSpPr/>
+          <p:nvPr/>
+        </p:nvSpPr>
+        <p:spPr>
+          <a:xfrm>
+            <a:off x="4528469" y="3231267"/>
+            <a:ext cx="1326812" cy="533017"/>
           </a:xfrm>
           <a:prstGeom prst="roundRect">
             <a:avLst/>
@@ -925,7 +1175,7 @@
           </a:solidFill>
           <a:ln w="12700">
             <a:solidFill>
-              <a:srgbClr val="8BADE3"/>
+              <a:srgbClr val="FB7185"/>
             </a:solidFill>
           </a:ln>
         </p:spPr>
@@ -958,14 +1208,14 @@
       </p:sp>
       <p:sp>
         <p:nvSpPr>
-          <p:cNvPr id="26" name="Node channels_github"/>
-          <p:cNvSpPr/>
-          <p:nvPr/>
-        </p:nvSpPr>
-        <p:spPr>
-          <a:xfrm>
-            <a:off x="7493804" y="2870576"/>
-            <a:ext cx="1539155" cy="540973"/>
+          <p:cNvPr id="33" name="Node channels_github"/>
+          <p:cNvSpPr/>
+          <p:nvPr/>
+        </p:nvSpPr>
+        <p:spPr>
+          <a:xfrm>
+            <a:off x="6336717" y="2560697"/>
+            <a:ext cx="1326812" cy="533017"/>
           </a:xfrm>
           <a:prstGeom prst="roundRect">
             <a:avLst/>
@@ -975,7 +1225,7 @@
           </a:solidFill>
           <a:ln w="12700">
             <a:solidFill>
-              <a:srgbClr val="8BADE3"/>
+              <a:srgbClr val="FB7185"/>
             </a:solidFill>
           </a:ln>
         </p:spPr>
@@ -997,14 +1247,14 @@
       </p:sp>
       <p:sp>
         <p:nvSpPr>
-          <p:cNvPr id="27" name="Node channels_content"/>
-          <p:cNvSpPr/>
-          <p:nvPr/>
-        </p:nvSpPr>
-        <p:spPr>
-          <a:xfrm>
-            <a:off x="7493804" y="3551155"/>
-            <a:ext cx="1539155" cy="540973"/>
+          <p:cNvPr id="34" name="Node channels_content"/>
+          <p:cNvSpPr/>
+          <p:nvPr/>
+        </p:nvSpPr>
+        <p:spPr>
+          <a:xfrm>
+            <a:off x="6336717" y="3231267"/>
+            <a:ext cx="1326812" cy="533017"/>
           </a:xfrm>
           <a:prstGeom prst="roundRect">
             <a:avLst/>
@@ -1014,7 +1264,7 @@
           </a:solidFill>
           <a:ln w="12700">
             <a:solidFill>
-              <a:srgbClr val="8BADE3"/>
+              <a:srgbClr val="FB7185"/>
             </a:solidFill>
           </a:ln>
         </p:spPr>
@@ -1047,14 +1297,14 @@
       </p:sp>
       <p:sp>
         <p:nvSpPr>
-          <p:cNvPr id="28" name="Node measurement_metrics"/>
-          <p:cNvSpPr/>
-          <p:nvPr/>
-        </p:nvSpPr>
-        <p:spPr>
-          <a:xfrm>
-            <a:off x="9661187" y="2870576"/>
-            <a:ext cx="1539155" cy="540973"/>
+          <p:cNvPr id="35" name="Node measurement_metrics"/>
+          <p:cNvSpPr/>
+          <p:nvPr/>
+        </p:nvSpPr>
+        <p:spPr>
+          <a:xfrm>
+            <a:off x="8144965" y="2560697"/>
+            <a:ext cx="1326812" cy="533017"/>
           </a:xfrm>
           <a:prstGeom prst="roundRect">
             <a:avLst/>
@@ -1064,7 +1314,7 @@
           </a:solidFill>
           <a:ln w="12700">
             <a:solidFill>
-              <a:srgbClr val="8BADE3"/>
+              <a:srgbClr val="FB7185"/>
             </a:solidFill>
           </a:ln>
         </p:spPr>
@@ -1097,14 +1347,14 @@
       </p:sp>
       <p:sp>
         <p:nvSpPr>
-          <p:cNvPr id="29" name="Node measurement_optimize"/>
-          <p:cNvSpPr/>
-          <p:nvPr/>
-        </p:nvSpPr>
-        <p:spPr>
-          <a:xfrm>
-            <a:off x="9661187" y="3551155"/>
-            <a:ext cx="1539155" cy="540973"/>
+          <p:cNvPr id="36" name="Node measurement_feedback"/>
+          <p:cNvSpPr/>
+          <p:nvPr/>
+        </p:nvSpPr>
+        <p:spPr>
+          <a:xfrm>
+            <a:off x="8144965" y="3231267"/>
+            <a:ext cx="1326812" cy="533017"/>
           </a:xfrm>
           <a:prstGeom prst="roundRect">
             <a:avLst/>
@@ -1114,7 +1364,57 @@
           </a:solidFill>
           <a:ln w="12700">
             <a:solidFill>
-              <a:srgbClr val="8BADE3"/>
+              <a:srgbClr val="FB7185"/>
+            </a:solidFill>
+          </a:ln>
+        </p:spPr>
+        <p:txBody>
+          <a:bodyPr wrap="square" anchor="ctr"/>
+          <a:lstStyle/>
+          <a:p>
+            <a:pPr algn="ctr"/>
+            <a:r>
+              <a:rPr lang="en-US" sz="1050">
+                <a:solidFill>
+                  <a:srgbClr val="111827"/>
+                </a:solidFill>
+              </a:rPr>
+              <a:t>Collect quality</a:t>
+            </a:r>
+          </a:p>
+          <a:p>
+            <a:pPr algn="ctr"/>
+            <a:r>
+              <a:rPr lang="en-US" sz="1050">
+                <a:solidFill>
+                  <a:srgbClr val="111827"/>
+                </a:solidFill>
+              </a:rPr>
+              <a:t>feedback</a:t>
+            </a:r>
+          </a:p>
+        </p:txBody>
+      </p:sp>
+      <p:sp>
+        <p:nvSpPr>
+          <p:cNvPr id="37" name="Node optimization_route"/>
+          <p:cNvSpPr/>
+          <p:nvPr/>
+        </p:nvSpPr>
+        <p:spPr>
+          <a:xfrm>
+            <a:off x="9953213" y="2560697"/>
+            <a:ext cx="1326812" cy="533017"/>
+          </a:xfrm>
+          <a:prstGeom prst="roundRect">
+            <a:avLst/>
+          </a:prstGeom>
+          <a:solidFill>
+            <a:srgbClr val="FFFFFF"/>
+          </a:solidFill>
+          <a:ln w="12700">
+            <a:solidFill>
+              <a:srgbClr val="FB7185"/>
             </a:solidFill>
           </a:ln>
         </p:spPr>

</xml_diff>